<commit_message>
M3: Update presentation with real training metrics (mAP50=0.892, P=0.938, R=0.809)
</commit_message>
<xml_diff>
--- a/Docs/G07_M3_Presentation.pptx
+++ b/Docs/G07_M3_Presentation.pptx
@@ -5452,7 +5452,7 @@
                 </a:solidFill>
                 <a:latin typeface="Calibri"/>
               </a:rPr>
-              <a:t>TBD*</a:t>
+              <a:t>0.892</a:t>
             </a:r>
           </a:p>
         </p:txBody>
@@ -5488,7 +5488,7 @@
                 <a:latin typeface="Calibri"/>
               </a:rPr>
               <a:t>mAP@50
-(detection)</a:t>
+(val, epoch 50)</a:t>
             </a:r>
           </a:p>
         </p:txBody>
@@ -5568,7 +5568,7 @@
                 </a:solidFill>
                 <a:latin typeface="Calibri"/>
               </a:rPr>
-              <a:t>TBD*</a:t>
+              <a:t>0.579</a:t>
             </a:r>
           </a:p>
         </p:txBody>
@@ -5684,7 +5684,7 @@
                 </a:solidFill>
                 <a:latin typeface="Calibri"/>
               </a:rPr>
-              <a:t>TBD*</a:t>
+              <a:t>0.938</a:t>
             </a:r>
           </a:p>
         </p:txBody>
@@ -5800,7 +5800,7 @@
                 </a:solidFill>
                 <a:latin typeface="Calibri"/>
               </a:rPr>
-              <a:t>TBD*</a:t>
+              <a:t>0.809</a:t>
             </a:r>
           </a:p>
         </p:txBody>
@@ -5916,7 +5916,7 @@
                 </a:solidFill>
                 <a:latin typeface="Calibri"/>
               </a:rPr>
-              <a:t>TBD*</a:t>
+              <a:t>50</a:t>
             </a:r>
           </a:p>
         </p:txBody>
@@ -5951,8 +5951,8 @@
                 </a:solidFill>
                 <a:latin typeface="Calibri"/>
               </a:rPr>
-              <a:t>Training
-Epochs</a:t>
+              <a:t>Epochs
+Completed</a:t>
             </a:r>
           </a:p>
         </p:txBody>
@@ -5983,11 +5983,11 @@
             <a:r>
               <a:rPr sz="1000" b="0">
                 <a:solidFill>
-                  <a:srgbClr val="FF8C00"/>
-                </a:solidFill>
-                <a:latin typeface="Calibri"/>
-              </a:rPr>
-              <a:t>* Values marked TBD will be updated after training completes on Google Colab</a:t>
+                  <a:srgbClr val="2ECC71"/>
+                </a:solidFill>
+                <a:latin typeface="Calibri"/>
+              </a:rPr>
+              <a:t>Training completed on Google Colab T4 GPU  |  Epoch 1 mAP50: 0.832  →  Epoch 50 mAP50: 0.892  (converged well)</a:t>
             </a:r>
           </a:p>
         </p:txBody>
@@ -6266,7 +6266,7 @@
                 </a:solidFill>
                 <a:latin typeface="Calibri"/>
               </a:rPr>
-              <a:t>Training Setup &amp; Expected Range</a:t>
+              <a:t>Training Setup &amp; Actual Results</a:t>
             </a:r>
           </a:p>
         </p:txBody>
@@ -6831,7 +6831,7 @@
                 </a:solidFill>
                 <a:latin typeface="Calibri"/>
               </a:rPr>
-              <a:t>50  (early stop: patience=20)</a:t>
+              <a:t>50 / 50 completed</a:t>
             </a:r>
           </a:p>
         </p:txBody>
@@ -6944,7 +6944,7 @@
                 </a:solidFill>
                 <a:latin typeface="Calibri"/>
               </a:rPr>
-              <a:t>16</a:t>
+              <a:t>16  |  Image size: 640 px</a:t>
             </a:r>
           </a:p>
         </p:txBody>
@@ -7022,7 +7022,7 @@
                 </a:solidFill>
                 <a:latin typeface="Calibri"/>
               </a:rPr>
-              <a:t>Image size:</a:t>
+              <a:t>GPU:</a:t>
             </a:r>
           </a:p>
         </p:txBody>
@@ -7057,7 +7057,7 @@
                 </a:solidFill>
                 <a:latin typeface="Calibri"/>
               </a:rPr>
-              <a:t>640 × 640 px</a:t>
+              <a:t>Google Colab T4</a:t>
             </a:r>
           </a:p>
         </p:txBody>
@@ -7135,7 +7135,7 @@
                 </a:solidFill>
                 <a:latin typeface="Calibri"/>
               </a:rPr>
-              <a:t>Optimizer:</a:t>
+              <a:t>box_loss (ep50):</a:t>
             </a:r>
           </a:p>
         </p:txBody>
@@ -7170,7 +7170,7 @@
                 </a:solidFill>
                 <a:latin typeface="Calibri"/>
               </a:rPr>
-              <a:t>AdamW (auto)</a:t>
+              <a:t>0.6501  (ep1: 1.388)</a:t>
             </a:r>
           </a:p>
         </p:txBody>
@@ -7248,7 +7248,7 @@
                 </a:solidFill>
                 <a:latin typeface="Calibri"/>
               </a:rPr>
-              <a:t>Training HW:</a:t>
+              <a:t>cls_loss (ep50):</a:t>
             </a:r>
           </a:p>
         </p:txBody>
@@ -7283,7 +7283,7 @@
                 </a:solidFill>
                 <a:latin typeface="Calibri"/>
               </a:rPr>
-              <a:t>Google Colab T4 GPU</a:t>
+              <a:t>0.3668  (ep1: 1.189)</a:t>
             </a:r>
           </a:p>
         </p:txBody>
@@ -7361,7 +7361,7 @@
                 </a:solidFill>
                 <a:latin typeface="Calibri"/>
               </a:rPr>
-              <a:t>Expected mAP@50:</a:t>
+              <a:t>mAP@50 achieved:</a:t>
             </a:r>
           </a:p>
         </p:txBody>
@@ -7396,7 +7396,7 @@
                 </a:solidFill>
                 <a:latin typeface="Calibri"/>
               </a:rPr>
-              <a:t>0.65 – 0.80  (typical range)</a:t>
+              <a:t>0.892  (target was &gt; 0.65)</a:t>
             </a:r>
           </a:p>
         </p:txBody>

</xml_diff>